<commit_message>
Use signature image for the manager's co-sign, prorate certificate hours
Both certificate templates now ship with the Talent Development Manager's
actual signature (a static image) instead of a typed name — nothing to
fill in per certificate anymore, so the old manual clone-a-shape-into-the-
male-template workaround is gone; both templates now natively carry a
trainer-name shape too (just named differently per template), simplifying
buildCertificatePptx.ts considerably.

Certificate hours are now prorated by the individual participant's actual
attendance at a fixed 4 hours/workshop-day, rather than a fixed total for
every certificate from a given workshop — a 5-day workshop attended in
full is 20 hours; attended 4 of 5 days (still ≥80%, still eligible) is 16.
Verified against real participants at both attendance levels.

Co-Authored-By: Claude Sonnet 5 <noreply@anthropic.com>
</commit_message>
<xml_diff>
--- a/backend/templates/certificate-template-female.pptx
+++ b/backend/templates/certificate-template-female.pptx
@@ -54,8 +54,8 @@
 <pc:chgInfo xmlns:a="http://schemas.openxmlformats.org/drawingml/2006/main" xmlns:r="http://schemas.openxmlformats.org/officeDocument/2006/relationships" xmlns:ac="http://schemas.microsoft.com/office/drawing/2013/main/command" xmlns:pc="http://schemas.microsoft.com/office/powerpoint/2013/main/command">
   <pc:docChgLst>
     <pc:chgData name="Sultan" userId="596bfde2-47e4-4d36-8f0a-78d31f84a794" providerId="ADAL" clId="{1076C667-93C1-4541-A912-C76B4913C881}"/>
-    <pc:docChg chg="delSld delSection modSection">
-      <pc:chgData name="Sultan" userId="596bfde2-47e4-4d36-8f0a-78d31f84a794" providerId="ADAL" clId="{1076C667-93C1-4541-A912-C76B4913C881}" dt="2026-07-29T09:06:22.710" v="1" actId="17851"/>
+    <pc:docChg chg="custSel delSld modSld delSection modSection">
+      <pc:chgData name="Sultan" userId="596bfde2-47e4-4d36-8f0a-78d31f84a794" providerId="ADAL" clId="{1076C667-93C1-4541-A912-C76B4913C881}" dt="2026-07-29T12:08:33.096" v="4" actId="1076"/>
       <pc:docMkLst>
         <pc:docMk/>
       </pc:docMkLst>
@@ -65,6 +65,29 @@
           <pc:docMk/>
           <pc:sldMk cId="0" sldId="256"/>
         </pc:sldMkLst>
+      </pc:sldChg>
+      <pc:sldChg chg="addSp delSp modSp mod">
+        <pc:chgData name="Sultan" userId="596bfde2-47e4-4d36-8f0a-78d31f84a794" providerId="ADAL" clId="{1076C667-93C1-4541-A912-C76B4913C881}" dt="2026-07-29T12:08:33.096" v="4" actId="1076"/>
+        <pc:sldMkLst>
+          <pc:docMk/>
+          <pc:sldMk cId="1491452707" sldId="258"/>
+        </pc:sldMkLst>
+        <pc:spChg chg="del">
+          <ac:chgData name="Sultan" userId="596bfde2-47e4-4d36-8f0a-78d31f84a794" providerId="ADAL" clId="{1076C667-93C1-4541-A912-C76B4913C881}" dt="2026-07-29T12:08:28.497" v="2" actId="478"/>
+          <ac:spMkLst>
+            <pc:docMk/>
+            <pc:sldMk cId="1491452707" sldId="258"/>
+            <ac:spMk id="3" creationId="{15D3936C-49FC-D788-1871-38574C6C8875}"/>
+          </ac:spMkLst>
+        </pc:spChg>
+        <pc:picChg chg="add mod">
+          <ac:chgData name="Sultan" userId="596bfde2-47e4-4d36-8f0a-78d31f84a794" providerId="ADAL" clId="{1076C667-93C1-4541-A912-C76B4913C881}" dt="2026-07-29T12:08:33.096" v="4" actId="1076"/>
+          <ac:picMkLst>
+            <pc:docMk/>
+            <pc:sldMk cId="1491452707" sldId="258"/>
+            <ac:picMk id="5" creationId="{E92D2507-B5B4-7B8F-E5D2-7B544C88CF72}"/>
+          </ac:picMkLst>
+        </pc:picChg>
       </pc:sldChg>
     </pc:docChg>
   </pc:docChgLst>
@@ -1861,55 +1884,36 @@
           </a:p>
         </p:txBody>
       </p:sp>
-      <p:sp>
-        <p:nvSpPr>
-          <p:cNvPr id="3" name="TextBox 2">
+      <p:pic>
+        <p:nvPicPr>
+          <p:cNvPr id="5" name="Picture 4">
             <a:extLst>
               <a:ext uri="{FF2B5EF4-FFF2-40B4-BE49-F238E27FC236}">
-                <a16:creationId xmlns:a16="http://schemas.microsoft.com/office/drawing/2014/main" id="{15D3936C-49FC-D788-1871-38574C6C8875}"/>
+                <a16:creationId xmlns:a16="http://schemas.microsoft.com/office/drawing/2014/main" id="{E92D2507-B5B4-7B8F-E5D2-7B544C88CF72}"/>
               </a:ext>
             </a:extLst>
           </p:cNvPr>
-          <p:cNvSpPr txBox="1"/>
+          <p:cNvPicPr>
+            <a:picLocks noChangeAspect="1"/>
+          </p:cNvPicPr>
           <p:nvPr/>
-        </p:nvSpPr>
+        </p:nvPicPr>
+        <p:blipFill>
+          <a:blip r:embed="rId3"/>
+          <a:stretch>
+            <a:fillRect/>
+          </a:stretch>
+        </p:blipFill>
         <p:spPr>
           <a:xfrm>
-            <a:off x="5727700" y="5985576"/>
-            <a:ext cx="3581400" cy="307777"/>
+            <a:off x="6718300" y="5922771"/>
+            <a:ext cx="1752600" cy="673100"/>
           </a:xfrm>
           <a:prstGeom prst="rect">
             <a:avLst/>
           </a:prstGeom>
-          <a:noFill/>
         </p:spPr>
-        <p:txBody>
-          <a:bodyPr wrap="square" rtlCol="0">
-            <a:spAutoFit/>
-          </a:bodyPr>
-          <a:lstStyle/>
-          <a:p>
-            <a:pPr algn="ctr"/>
-            <a:r>
-              <a:rPr lang="ar-SA" sz="1400" b="1" dirty="0">
-                <a:solidFill>
-                  <a:srgbClr val="B41E34"/>
-                </a:solidFill>
-                <a:latin typeface="Effra" panose="020B0603020203020204" pitchFamily="34" charset="0"/>
-                <a:cs typeface="Effra" panose="020B0603020203020204" pitchFamily="34" charset="0"/>
-              </a:rPr>
-              <a:t>المثنى كتبي</a:t>
-            </a:r>
-            <a:endParaRPr lang="en-US" sz="1400" b="1" dirty="0">
-              <a:solidFill>
-                <a:srgbClr val="B41E34"/>
-              </a:solidFill>
-              <a:latin typeface="Effra" panose="020B0603020203020204" pitchFamily="34" charset="0"/>
-              <a:cs typeface="Effra" panose="020B0603020203020204" pitchFamily="34" charset="0"/>
-            </a:endParaRPr>
-          </a:p>
-        </p:txBody>
-      </p:sp>
+      </p:pic>
     </p:spTree>
     <p:extLst>
       <p:ext uri="{BB962C8B-B14F-4D97-AF65-F5344CB8AC3E}">

</xml_diff>